<commit_message>
Update AI에게 정답 듣기 assets and add ZIP slides
Co-Authored-By: Claude Opus 4.6 (1M context) <noreply@anthropic.com>
</commit_message>
<xml_diff>
--- a/public/downloads/games/ai-answer/rules.pptx
+++ b/public/downloads/games/ai-answer/rules.pptx
@@ -25,16 +25,12 @@
   <p:notesSz cx="6858000" cy="9144000"/>
   <p:embeddedFontLst>
     <p:embeddedFont>
-      <p:font typeface="Jua" charset="1" panose="00000000000000000000"/>
+      <p:font typeface="무궁화 고딕" charset="1" panose="02020603020101020101"/>
       <p:regular r:id="rId21"/>
     </p:embeddedFont>
     <p:embeddedFont>
-      <p:font typeface="TDTD갬성명조" charset="1" panose="02000503000000000000"/>
+      <p:font typeface="무궁화 고딕 Bold" charset="1" panose="02020603020101020101"/>
       <p:regular r:id="rId22"/>
-    </p:embeddedFont>
-    <p:embeddedFont>
-      <p:font typeface="TDTD가온" charset="1" panose="02000503000000000000"/>
-      <p:regular r:id="rId23"/>
     </p:embeddedFont>
   </p:embeddedFontLst>
   <p:defaultTextStyle>
@@ -3152,8 +3148,8 @@
         </p:nvSpPr>
         <p:spPr>
           <a:xfrm rot="0">
-            <a:off x="1028700" y="3892867"/>
-            <a:ext cx="15555091" cy="2200275"/>
+            <a:off x="1028700" y="4178617"/>
+            <a:ext cx="15555091" cy="1914525"/>
           </a:xfrm>
           <a:prstGeom prst="rect">
             <a:avLst/>
@@ -3175,10 +3171,10 @@
                 <a:solidFill>
                   <a:srgbClr val="FFFAEF"/>
                 </a:solidFill>
-                <a:latin typeface="Jua"/>
-                <a:ea typeface="Jua"/>
-                <a:cs typeface="Jua"/>
-                <a:sym typeface="Jua"/>
+                <a:latin typeface="무궁화 고딕"/>
+                <a:ea typeface="무궁화 고딕"/>
+                <a:cs typeface="무궁화 고딕"/>
+                <a:sym typeface="무궁화 고딕"/>
               </a:rPr>
               <a:t>AI에게 정답 듣기</a:t>
             </a:r>
@@ -3193,8 +3189,8 @@
         </p:nvSpPr>
         <p:spPr>
           <a:xfrm rot="0">
-            <a:off x="15264803" y="9812655"/>
-            <a:ext cx="2637975" cy="474345"/>
+            <a:off x="14121803" y="9822180"/>
+            <a:ext cx="3780975" cy="464820"/>
           </a:xfrm>
           <a:prstGeom prst="rect">
             <a:avLst/>
@@ -3219,10 +3215,10 @@
                 <a:solidFill>
                   <a:srgbClr val="FFFFFF"/>
                 </a:solidFill>
-                <a:latin typeface="TDTD갬성명조"/>
-                <a:ea typeface="TDTD갬성명조"/>
-                <a:cs typeface="TDTD갬성명조"/>
-                <a:sym typeface="TDTD갬성명조"/>
+                <a:latin typeface="무궁화 고딕"/>
+                <a:ea typeface="무궁화 고딕"/>
+                <a:cs typeface="무궁화 고딕"/>
+                <a:sym typeface="무궁화 고딕"/>
               </a:rPr>
               <a:t>ⓒ 2026. Sunday Play</a:t>
             </a:r>
@@ -3269,8 +3265,8 @@
         </p:nvSpPr>
         <p:spPr>
           <a:xfrm rot="0">
-            <a:off x="3238925" y="4092795"/>
-            <a:ext cx="11810151" cy="2200275"/>
+            <a:off x="3238925" y="4378545"/>
+            <a:ext cx="11810151" cy="1914525"/>
           </a:xfrm>
           <a:prstGeom prst="rect">
             <a:avLst/>
@@ -3292,10 +3288,10 @@
                 <a:solidFill>
                   <a:srgbClr val="000000"/>
                 </a:solidFill>
-                <a:latin typeface="Jua"/>
-                <a:ea typeface="Jua"/>
-                <a:cs typeface="Jua"/>
-                <a:sym typeface="Jua"/>
+                <a:latin typeface="무궁화 고딕"/>
+                <a:ea typeface="무궁화 고딕"/>
+                <a:cs typeface="무궁화 고딕"/>
+                <a:sym typeface="무궁화 고딕"/>
               </a:rPr>
               <a:t>웃으면 복이 온다</a:t>
             </a:r>
@@ -3392,8 +3388,8 @@
         </p:nvSpPr>
         <p:spPr>
           <a:xfrm rot="0">
-            <a:off x="3238925" y="4092795"/>
-            <a:ext cx="11810151" cy="2200275"/>
+            <a:off x="3238925" y="4378545"/>
+            <a:ext cx="11810151" cy="1914525"/>
           </a:xfrm>
           <a:prstGeom prst="rect">
             <a:avLst/>
@@ -3415,10 +3411,10 @@
                 <a:solidFill>
                   <a:srgbClr val="000000"/>
                 </a:solidFill>
-                <a:latin typeface="Jua"/>
-                <a:ea typeface="Jua"/>
-                <a:cs typeface="Jua"/>
-                <a:sym typeface="Jua"/>
+                <a:latin typeface="무궁화 고딕"/>
+                <a:ea typeface="무궁화 고딕"/>
+                <a:cs typeface="무궁화 고딕"/>
+                <a:sym typeface="무궁화 고딕"/>
               </a:rPr>
               <a:t>백문이 불여일견</a:t>
             </a:r>
@@ -3515,8 +3511,8 @@
         </p:nvSpPr>
         <p:spPr>
           <a:xfrm rot="0">
-            <a:off x="1795135" y="2943225"/>
-            <a:ext cx="14697730" cy="4105275"/>
+            <a:off x="1795135" y="3324225"/>
+            <a:ext cx="14697730" cy="3629025"/>
           </a:xfrm>
           <a:prstGeom prst="rect">
             <a:avLst/>
@@ -3530,18 +3526,18 @@
           <a:p>
             <a:pPr algn="ctr">
               <a:lnSpc>
-                <a:spcPts val="15000"/>
+                <a:spcPts val="14280"/>
               </a:lnSpc>
             </a:pPr>
             <a:r>
-              <a:rPr lang="en-US" sz="12500">
+              <a:rPr lang="en-US" sz="11900">
                 <a:solidFill>
                   <a:srgbClr val="000000"/>
                 </a:solidFill>
-                <a:latin typeface="Jua"/>
-                <a:ea typeface="Jua"/>
-                <a:cs typeface="Jua"/>
-                <a:sym typeface="Jua"/>
+                <a:latin typeface="무궁화 고딕"/>
+                <a:ea typeface="무궁화 고딕"/>
+                <a:cs typeface="무궁화 고딕"/>
+                <a:sym typeface="무궁화 고딕"/>
               </a:rPr>
               <a:t>세상에서 제일 맛있는 건 엄마가 해준 밥</a:t>
             </a:r>
@@ -3638,8 +3634,8 @@
         </p:nvSpPr>
         <p:spPr>
           <a:xfrm rot="0">
-            <a:off x="3238925" y="4092795"/>
-            <a:ext cx="11810151" cy="2200275"/>
+            <a:off x="3238925" y="4378545"/>
+            <a:ext cx="11810151" cy="1914525"/>
           </a:xfrm>
           <a:prstGeom prst="rect">
             <a:avLst/>
@@ -3661,10 +3657,10 @@
                 <a:solidFill>
                   <a:srgbClr val="000000"/>
                 </a:solidFill>
-                <a:latin typeface="Jua"/>
-                <a:ea typeface="Jua"/>
-                <a:cs typeface="Jua"/>
-                <a:sym typeface="Jua"/>
+                <a:latin typeface="무궁화 고딕"/>
+                <a:ea typeface="무궁화 고딕"/>
+                <a:cs typeface="무궁화 고딕"/>
+                <a:sym typeface="무궁화 고딕"/>
               </a:rPr>
               <a:t>모르겠어요</a:t>
             </a:r>
@@ -3761,8 +3757,8 @@
         </p:nvSpPr>
         <p:spPr>
           <a:xfrm rot="0">
-            <a:off x="2015714" y="3895725"/>
-            <a:ext cx="14256572" cy="2200275"/>
+            <a:off x="2015714" y="4257675"/>
+            <a:ext cx="14256572" cy="1762125"/>
           </a:xfrm>
           <a:prstGeom prst="rect">
             <a:avLst/>
@@ -3776,18 +3772,18 @@
           <a:p>
             <a:pPr algn="ctr">
               <a:lnSpc>
-                <a:spcPts val="15000"/>
+                <a:spcPts val="13800"/>
               </a:lnSpc>
             </a:pPr>
             <a:r>
-              <a:rPr lang="en-US" sz="12500">
+              <a:rPr lang="en-US" sz="11500">
                 <a:solidFill>
                   <a:srgbClr val="000000"/>
                 </a:solidFill>
-                <a:latin typeface="Jua"/>
-                <a:ea typeface="Jua"/>
-                <a:cs typeface="Jua"/>
-                <a:sym typeface="Jua"/>
+                <a:latin typeface="무궁화 고딕"/>
+                <a:ea typeface="무궁화 고딕"/>
+                <a:cs typeface="무궁화 고딕"/>
+                <a:sym typeface="무궁화 고딕"/>
               </a:rPr>
               <a:t>다시 한번 말씀해 주세요</a:t>
             </a:r>
@@ -3909,8 +3905,8 @@
         </p:nvSpPr>
         <p:spPr>
           <a:xfrm rot="0">
-            <a:off x="4421807" y="3895725"/>
-            <a:ext cx="9444385" cy="2200275"/>
+            <a:off x="4421807" y="4181475"/>
+            <a:ext cx="9444385" cy="1914525"/>
           </a:xfrm>
           <a:prstGeom prst="rect">
             <a:avLst/>
@@ -3932,10 +3928,10 @@
                 <a:solidFill>
                   <a:srgbClr val="000000"/>
                 </a:solidFill>
-                <a:latin typeface="Jua"/>
-                <a:ea typeface="Jua"/>
-                <a:cs typeface="Jua"/>
-                <a:sym typeface="Jua"/>
+                <a:latin typeface="무궁화 고딕"/>
+                <a:ea typeface="무궁화 고딕"/>
+                <a:cs typeface="무궁화 고딕"/>
+                <a:sym typeface="무궁화 고딕"/>
               </a:rPr>
               <a:t>감사합니다!</a:t>
             </a:r>
@@ -4134,8 +4130,8 @@
         </p:nvSpPr>
         <p:spPr>
           <a:xfrm rot="0">
-            <a:off x="11392761" y="600705"/>
-            <a:ext cx="5362043" cy="1600200"/>
+            <a:off x="11392761" y="819780"/>
+            <a:ext cx="5362043" cy="1381125"/>
           </a:xfrm>
           <a:prstGeom prst="rect">
             <a:avLst/>
@@ -4157,10 +4153,10 @@
                 <a:solidFill>
                   <a:srgbClr val="FFFAEF"/>
                 </a:solidFill>
-                <a:latin typeface="Jua"/>
-                <a:ea typeface="Jua"/>
-                <a:cs typeface="Jua"/>
-                <a:sym typeface="Jua"/>
+                <a:latin typeface="무궁화 고딕"/>
+                <a:ea typeface="무궁화 고딕"/>
+                <a:cs typeface="무궁화 고딕"/>
+                <a:sym typeface="무궁화 고딕"/>
               </a:rPr>
               <a:t>규칙</a:t>
             </a:r>
@@ -4176,9 +4172,9 @@
         <p:grpSpPr>
           <a:xfrm rot="0">
             <a:off x="309172" y="535073"/>
-            <a:ext cx="10694683" cy="1779769"/>
+            <a:ext cx="10694683" cy="1701684"/>
             <a:chOff x="0" y="0"/>
-            <a:chExt cx="14259577" cy="2373026"/>
+            <a:chExt cx="14259577" cy="2268911"/>
           </a:xfrm>
         </p:grpSpPr>
         <p:sp>
@@ -4189,8 +4185,8 @@
           </p:nvSpPr>
           <p:spPr>
             <a:xfrm rot="0">
-              <a:off x="0" y="1380584"/>
-              <a:ext cx="14259577" cy="992442"/>
+              <a:off x="0" y="1388378"/>
+              <a:ext cx="14259577" cy="880533"/>
             </a:xfrm>
             <a:prstGeom prst="rect">
               <a:avLst/>
@@ -4204,30 +4200,30 @@
             <a:p>
               <a:pPr algn="l">
                 <a:lnSpc>
-                  <a:spcPts val="6273"/>
+                  <a:spcPts val="5599"/>
                 </a:lnSpc>
               </a:pPr>
               <a:r>
-                <a:rPr lang="en-US" sz="4480">
+                <a:rPr lang="en-US" sz="3999">
                   <a:solidFill>
                     <a:srgbClr val="FFFAEF"/>
                   </a:solidFill>
-                  <a:latin typeface="TDTD가온"/>
-                  <a:ea typeface="TDTD가온"/>
-                  <a:cs typeface="TDTD가온"/>
-                  <a:sym typeface="TDTD가온"/>
+                  <a:latin typeface="무궁화 고딕"/>
+                  <a:ea typeface="무궁화 고딕"/>
+                  <a:cs typeface="무궁화 고딕"/>
+                  <a:sym typeface="무궁화 고딕"/>
                 </a:rPr>
                 <a:t>각 팀 대표 1명</a:t>
               </a:r>
               <a:r>
-                <a:rPr lang="en-US" sz="4480">
+                <a:rPr lang="en-US" sz="3999">
                   <a:solidFill>
                     <a:srgbClr val="FFFAEF"/>
                   </a:solidFill>
-                  <a:latin typeface="TDTD가온"/>
-                  <a:ea typeface="TDTD가온"/>
-                  <a:cs typeface="TDTD가온"/>
-                  <a:sym typeface="TDTD가온"/>
+                  <a:latin typeface="무궁화 고딕"/>
+                  <a:ea typeface="무궁화 고딕"/>
+                  <a:cs typeface="무궁화 고딕"/>
+                  <a:sym typeface="무궁화 고딕"/>
                 </a:rPr>
                 <a:t>이 나오고, 화면에 문장이 공개됩니다.</a:t>
               </a:r>
@@ -4242,8 +4238,8 @@
           </p:nvSpPr>
           <p:spPr>
             <a:xfrm rot="0">
-              <a:off x="0" y="-171450"/>
-              <a:ext cx="9574913" cy="1169217"/>
+              <a:off x="0" y="-66675"/>
+              <a:ext cx="9574913" cy="1062712"/>
             </a:xfrm>
             <a:prstGeom prst="rect">
               <a:avLst/>
@@ -4265,10 +4261,10 @@
                   <a:solidFill>
                     <a:srgbClr val="FFFAEF"/>
                   </a:solidFill>
-                  <a:latin typeface="Jua"/>
-                  <a:ea typeface="Jua"/>
-                  <a:cs typeface="Jua"/>
-                  <a:sym typeface="Jua"/>
+                  <a:latin typeface="무궁화 고딕 Bold"/>
+                  <a:ea typeface="무궁화 고딕 Bold"/>
+                  <a:cs typeface="무궁화 고딕 Bold"/>
+                  <a:sym typeface="무궁화 고딕 Bold"/>
                 </a:rPr>
                 <a:t>STEP 1.</a:t>
               </a:r>
@@ -4285,9 +4281,9 @@
         <p:grpSpPr>
           <a:xfrm rot="0">
             <a:off x="9546476" y="8305238"/>
-            <a:ext cx="8487123" cy="1778769"/>
+            <a:ext cx="8487123" cy="1697862"/>
             <a:chOff x="0" y="0"/>
-            <a:chExt cx="11316164" cy="2371692"/>
+            <a:chExt cx="11316164" cy="2263816"/>
           </a:xfrm>
         </p:grpSpPr>
         <p:sp>
@@ -4298,8 +4294,8 @@
           </p:nvSpPr>
           <p:spPr>
             <a:xfrm rot="0">
-              <a:off x="0" y="1377534"/>
-              <a:ext cx="11143161" cy="994158"/>
+              <a:off x="0" y="1373758"/>
+              <a:ext cx="11143161" cy="890058"/>
             </a:xfrm>
             <a:prstGeom prst="rect">
               <a:avLst/>
@@ -4313,30 +4309,30 @@
             <a:p>
               <a:pPr algn="l">
                 <a:lnSpc>
-                  <a:spcPts val="6284"/>
+                  <a:spcPts val="5600"/>
                 </a:lnSpc>
               </a:pPr>
               <a:r>
-                <a:rPr lang="en-US" sz="4489">
+                <a:rPr lang="en-US" sz="4000">
                   <a:solidFill>
                     <a:srgbClr val="FFFAEF"/>
                   </a:solidFill>
-                  <a:latin typeface="TDTD가온"/>
-                  <a:ea typeface="TDTD가온"/>
-                  <a:cs typeface="TDTD가온"/>
-                  <a:sym typeface="TDTD가온"/>
+                  <a:latin typeface="무궁화 고딕"/>
+                  <a:ea typeface="무궁화 고딕"/>
+                  <a:cs typeface="무궁화 고딕"/>
+                  <a:sym typeface="무궁화 고딕"/>
                 </a:rPr>
                 <a:t>가장 빠른</a:t>
               </a:r>
               <a:r>
-                <a:rPr lang="en-US" sz="4489">
+                <a:rPr lang="en-US" sz="4000">
                   <a:solidFill>
                     <a:srgbClr val="FFFAEF"/>
                   </a:solidFill>
-                  <a:latin typeface="TDTD가온"/>
-                  <a:ea typeface="TDTD가온"/>
-                  <a:cs typeface="TDTD가온"/>
-                  <a:sym typeface="TDTD가온"/>
+                  <a:latin typeface="무궁화 고딕"/>
+                  <a:ea typeface="무궁화 고딕"/>
+                  <a:cs typeface="무궁화 고딕"/>
+                  <a:sym typeface="무궁화 고딕"/>
                 </a:rPr>
                 <a:t> 시간 안에 성공한 팀이 승리!</a:t>
               </a:r>
@@ -4351,8 +4347,8 @@
           </p:nvSpPr>
           <p:spPr>
             <a:xfrm rot="0">
-              <a:off x="0" y="-171450"/>
-              <a:ext cx="11316164" cy="1171105"/>
+              <a:off x="0" y="-57150"/>
+              <a:ext cx="11316164" cy="1053029"/>
             </a:xfrm>
             <a:prstGeom prst="rect">
               <a:avLst/>
@@ -4374,10 +4370,10 @@
                   <a:solidFill>
                     <a:srgbClr val="FFFAEF"/>
                   </a:solidFill>
-                  <a:latin typeface="Jua"/>
-                  <a:ea typeface="Jua"/>
-                  <a:cs typeface="Jua"/>
-                  <a:sym typeface="Jua"/>
+                  <a:latin typeface="무궁화 고딕 Bold"/>
+                  <a:ea typeface="무궁화 고딕 Bold"/>
+                  <a:cs typeface="무궁화 고딕 Bold"/>
+                  <a:sym typeface="무궁화 고딕 Bold"/>
                 </a:rPr>
                 <a:t>STEP 3.</a:t>
               </a:r>
@@ -4394,9 +4390,9 @@
         <p:grpSpPr>
           <a:xfrm rot="0">
             <a:off x="4044594" y="4025016"/>
-            <a:ext cx="10397630" cy="2570047"/>
+            <a:ext cx="10397630" cy="2402261"/>
             <a:chOff x="0" y="0"/>
-            <a:chExt cx="13863507" cy="3426730"/>
+            <a:chExt cx="13863507" cy="3203015"/>
           </a:xfrm>
         </p:grpSpPr>
         <p:sp>
@@ -4407,8 +4403,8 @@
           </p:nvSpPr>
           <p:spPr>
             <a:xfrm rot="0">
-              <a:off x="0" y="1375218"/>
-              <a:ext cx="13863507" cy="2051512"/>
+              <a:off x="0" y="1382681"/>
+              <a:ext cx="13863507" cy="1820333"/>
             </a:xfrm>
             <a:prstGeom prst="rect">
               <a:avLst/>
@@ -4422,18 +4418,18 @@
             <a:p>
               <a:pPr algn="l">
                 <a:lnSpc>
-                  <a:spcPts val="6275"/>
+                  <a:spcPts val="5599"/>
                 </a:lnSpc>
               </a:pPr>
               <a:r>
-                <a:rPr lang="en-US" sz="4482">
+                <a:rPr lang="en-US" sz="3999">
                   <a:solidFill>
                     <a:srgbClr val="FFFAEF"/>
                   </a:solidFill>
-                  <a:latin typeface="TDTD가온"/>
-                  <a:ea typeface="TDTD가온"/>
-                  <a:cs typeface="TDTD가온"/>
-                  <a:sym typeface="TDTD가온"/>
+                  <a:latin typeface="무궁화 고딕"/>
+                  <a:ea typeface="무궁화 고딕"/>
+                  <a:cs typeface="무궁화 고딕"/>
+                  <a:sym typeface="무궁화 고딕"/>
                 </a:rPr>
                 <a:t>대표가 AI에게 질문하여 목표 문장을 말하게 하세요.                                </a:t>
               </a:r>
@@ -4441,18 +4437,18 @@
             <a:p>
               <a:pPr algn="l">
                 <a:lnSpc>
-                  <a:spcPts val="6275"/>
+                  <a:spcPts val="5599"/>
                 </a:lnSpc>
               </a:pPr>
               <a:r>
-                <a:rPr lang="en-US" sz="4482">
+                <a:rPr lang="en-US" sz="3999">
                   <a:solidFill>
                     <a:srgbClr val="FFFAEF"/>
                   </a:solidFill>
-                  <a:latin typeface="TDTD가온"/>
-                  <a:ea typeface="TDTD가온"/>
-                  <a:cs typeface="TDTD가온"/>
-                  <a:sym typeface="TDTD가온"/>
+                  <a:latin typeface="무궁화 고딕"/>
+                  <a:ea typeface="무궁화 고딕"/>
+                  <a:cs typeface="무궁화 고딕"/>
+                  <a:sym typeface="무궁화 고딕"/>
                 </a:rPr>
                 <a:t> 단, "~라고 말해줘" 같은 직접 지시는 금지!</a:t>
               </a:r>
@@ -4467,8 +4463,8 @@
           </p:nvSpPr>
           <p:spPr>
             <a:xfrm rot="0">
-              <a:off x="0" y="-171450"/>
-              <a:ext cx="6898637" cy="1169523"/>
+              <a:off x="0" y="-57150"/>
+              <a:ext cx="6898637" cy="1053161"/>
             </a:xfrm>
             <a:prstGeom prst="rect">
               <a:avLst/>
@@ -4490,10 +4486,10 @@
                   <a:solidFill>
                     <a:srgbClr val="FFFAEF"/>
                   </a:solidFill>
-                  <a:latin typeface="Jua"/>
-                  <a:ea typeface="Jua"/>
-                  <a:cs typeface="Jua"/>
-                  <a:sym typeface="Jua"/>
+                  <a:latin typeface="무궁화 고딕 Bold"/>
+                  <a:ea typeface="무궁화 고딕 Bold"/>
+                  <a:cs typeface="무궁화 고딕 Bold"/>
+                  <a:sym typeface="무궁화 고딕 Bold"/>
                 </a:rPr>
                 <a:t>STEP 2.</a:t>
               </a:r>
@@ -4541,8 +4537,8 @@
         </p:nvSpPr>
         <p:spPr>
           <a:xfrm rot="0">
-            <a:off x="3238925" y="4092795"/>
-            <a:ext cx="11810151" cy="2200275"/>
+            <a:off x="3238925" y="4378545"/>
+            <a:ext cx="11810151" cy="1914525"/>
           </a:xfrm>
           <a:prstGeom prst="rect">
             <a:avLst/>
@@ -4564,10 +4560,10 @@
                 <a:solidFill>
                   <a:srgbClr val="000000"/>
                 </a:solidFill>
-                <a:latin typeface="Jua"/>
-                <a:ea typeface="Jua"/>
-                <a:cs typeface="Jua"/>
-                <a:sym typeface="Jua"/>
+                <a:latin typeface="무궁화 고딕"/>
+                <a:ea typeface="무궁화 고딕"/>
+                <a:cs typeface="무궁화 고딕"/>
+                <a:sym typeface="무궁화 고딕"/>
               </a:rPr>
               <a:t>팀을 나눠주세요!</a:t>
             </a:r>
@@ -4714,8 +4710,8 @@
         </p:nvSpPr>
         <p:spPr>
           <a:xfrm rot="0">
-            <a:off x="1028700" y="3892867"/>
-            <a:ext cx="15555091" cy="2200275"/>
+            <a:off x="1028700" y="4178617"/>
+            <a:ext cx="15555091" cy="1914525"/>
           </a:xfrm>
           <a:prstGeom prst="rect">
             <a:avLst/>
@@ -4737,10 +4733,10 @@
                 <a:solidFill>
                   <a:srgbClr val="FFFAEF"/>
                 </a:solidFill>
-                <a:latin typeface="Jua"/>
-                <a:ea typeface="Jua"/>
-                <a:cs typeface="Jua"/>
-                <a:sym typeface="Jua"/>
+                <a:latin typeface="무궁화 고딕"/>
+                <a:ea typeface="무궁화 고딕"/>
+                <a:cs typeface="무궁화 고딕"/>
+                <a:sym typeface="무궁화 고딕"/>
               </a:rPr>
               <a:t>AI에게 정답 듣기</a:t>
             </a:r>
@@ -4755,8 +4751,8 @@
         </p:nvSpPr>
         <p:spPr>
           <a:xfrm rot="0">
-            <a:off x="15264803" y="9812655"/>
-            <a:ext cx="2637975" cy="474345"/>
+            <a:off x="14121803" y="9822180"/>
+            <a:ext cx="3780975" cy="464820"/>
           </a:xfrm>
           <a:prstGeom prst="rect">
             <a:avLst/>
@@ -4781,10 +4777,10 @@
                 <a:solidFill>
                   <a:srgbClr val="FFFFFF"/>
                 </a:solidFill>
-                <a:latin typeface="TDTD갬성명조"/>
-                <a:ea typeface="TDTD갬성명조"/>
-                <a:cs typeface="TDTD갬성명조"/>
-                <a:sym typeface="TDTD갬성명조"/>
+                <a:latin typeface="무궁화 고딕"/>
+                <a:ea typeface="무궁화 고딕"/>
+                <a:cs typeface="무궁화 고딕"/>
+                <a:sym typeface="무궁화 고딕"/>
               </a:rPr>
               <a:t>ⓒ 2026. Sunday Play</a:t>
             </a:r>
@@ -4831,8 +4827,8 @@
         </p:nvSpPr>
         <p:spPr>
           <a:xfrm rot="0">
-            <a:off x="3238925" y="4092795"/>
-            <a:ext cx="11810151" cy="2200275"/>
+            <a:off x="3238925" y="4378545"/>
+            <a:ext cx="11810151" cy="1914525"/>
           </a:xfrm>
           <a:prstGeom prst="rect">
             <a:avLst/>
@@ -4854,10 +4850,10 @@
                 <a:solidFill>
                   <a:srgbClr val="000000"/>
                 </a:solidFill>
-                <a:latin typeface="Jua"/>
-                <a:ea typeface="Jua"/>
-                <a:cs typeface="Jua"/>
-                <a:sym typeface="Jua"/>
+                <a:latin typeface="무궁화 고딕"/>
+                <a:ea typeface="무궁화 고딕"/>
+                <a:cs typeface="무궁화 고딕"/>
+                <a:sym typeface="무궁화 고딕"/>
               </a:rPr>
               <a:t>사랑합니다</a:t>
             </a:r>
@@ -4954,8 +4950,8 @@
         </p:nvSpPr>
         <p:spPr>
           <a:xfrm rot="0">
-            <a:off x="3238925" y="4092795"/>
-            <a:ext cx="11810151" cy="2200275"/>
+            <a:off x="3238925" y="4378545"/>
+            <a:ext cx="11810151" cy="1914525"/>
           </a:xfrm>
           <a:prstGeom prst="rect">
             <a:avLst/>
@@ -4977,10 +4973,10 @@
                 <a:solidFill>
                   <a:srgbClr val="000000"/>
                 </a:solidFill>
-                <a:latin typeface="Jua"/>
-                <a:ea typeface="Jua"/>
-                <a:cs typeface="Jua"/>
-                <a:sym typeface="Jua"/>
+                <a:latin typeface="무궁화 고딕"/>
+                <a:ea typeface="무궁화 고딕"/>
+                <a:cs typeface="무궁화 고딕"/>
+                <a:sym typeface="무궁화 고딕"/>
               </a:rPr>
               <a:t>감사합니다</a:t>
             </a:r>
@@ -5077,8 +5073,8 @@
         </p:nvSpPr>
         <p:spPr>
           <a:xfrm rot="0">
-            <a:off x="3238925" y="4092795"/>
-            <a:ext cx="11810151" cy="2200275"/>
+            <a:off x="3238925" y="4378545"/>
+            <a:ext cx="11810151" cy="1914525"/>
           </a:xfrm>
           <a:prstGeom prst="rect">
             <a:avLst/>
@@ -5100,10 +5096,10 @@
                 <a:solidFill>
                   <a:srgbClr val="000000"/>
                 </a:solidFill>
-                <a:latin typeface="Jua"/>
-                <a:ea typeface="Jua"/>
-                <a:cs typeface="Jua"/>
-                <a:sym typeface="Jua"/>
+                <a:latin typeface="무궁화 고딕"/>
+                <a:ea typeface="무궁화 고딕"/>
+                <a:cs typeface="무궁화 고딕"/>
+                <a:sym typeface="무궁화 고딕"/>
               </a:rPr>
               <a:t>화이팅(파이팅)</a:t>
             </a:r>
@@ -5200,8 +5196,8 @@
         </p:nvSpPr>
         <p:spPr>
           <a:xfrm rot="0">
-            <a:off x="3238925" y="4092795"/>
-            <a:ext cx="11810151" cy="2200275"/>
+            <a:off x="3238925" y="4378545"/>
+            <a:ext cx="11810151" cy="1914525"/>
           </a:xfrm>
           <a:prstGeom prst="rect">
             <a:avLst/>
@@ -5223,10 +5219,10 @@
                 <a:solidFill>
                   <a:srgbClr val="000000"/>
                 </a:solidFill>
-                <a:latin typeface="Jua"/>
-                <a:ea typeface="Jua"/>
-                <a:cs typeface="Jua"/>
-                <a:sym typeface="Jua"/>
+                <a:latin typeface="무궁화 고딕"/>
+                <a:ea typeface="무궁화 고딕"/>
+                <a:cs typeface="무궁화 고딕"/>
+                <a:sym typeface="무궁화 고딕"/>
               </a:rPr>
               <a:t>시작이 반이다</a:t>
             </a:r>
@@ -5323,8 +5319,8 @@
         </p:nvSpPr>
         <p:spPr>
           <a:xfrm rot="0">
-            <a:off x="3238925" y="4092795"/>
-            <a:ext cx="11810151" cy="2200275"/>
+            <a:off x="3238925" y="4378545"/>
+            <a:ext cx="11810151" cy="1914525"/>
           </a:xfrm>
           <a:prstGeom prst="rect">
             <a:avLst/>
@@ -5346,10 +5342,10 @@
                 <a:solidFill>
                   <a:srgbClr val="000000"/>
                 </a:solidFill>
-                <a:latin typeface="Jua"/>
-                <a:ea typeface="Jua"/>
-                <a:cs typeface="Jua"/>
-                <a:sym typeface="Jua"/>
+                <a:latin typeface="무궁화 고딕"/>
+                <a:ea typeface="무궁화 고딕"/>
+                <a:cs typeface="무궁화 고딕"/>
+                <a:sym typeface="무궁화 고딕"/>
               </a:rPr>
               <a:t>포기하지 마세요</a:t>
             </a:r>

</xml_diff>